<commit_message>
report and deck: fix figure and float layout
Report:
- the interface listing was breaking across a column boundary; it is now a
  float (Fig. 2) so it stays whole
- the aerial scenario figure was a full-width float stranded on the last page,
  away from the text discussing it; it is now a single-column figure adjacent
  to the cross-domain subsection
- balance the final page, which had one full column and one empty
- shorten the margin-table caption

Figures:
- new scripts/tighten_figure.py drops the outer white margin and any wide
  internal gutter. Both scenario figures had a title band spanning a margin no
  panel used, costing ~19% of the driving figure's width and ~24% of the
  aerial one's; the captions already carry that title
- the risk-coverage legend sat on top of the v2 line at 2.324; moved

Deck picks up the tightened figures and its two scenario slides are resized to
suit their new aspect ratios.
</commit_message>
<xml_diff>
--- a/docs/NeuFlow_v3_Presentation.pptx
+++ b/docs/NeuFlow_v3_Presentation.pptx
@@ -5928,7 +5928,7 @@
       </p:sp>
       <p:pic>
         <p:nvPicPr>
-          <p:cNvPr id="5" name="Picture 4" descr="scenarios_illustrated.png"/>
+          <p:cNvPr id="5" name="Picture 4" descr="scenarios_illustrated_tight.png"/>
           <p:cNvPicPr>
             <a:picLocks noChangeAspect="1"/>
           </p:cNvPicPr>
@@ -5942,8 +5942,8 @@
         </p:blipFill>
         <p:spPr>
           <a:xfrm>
-            <a:off x="868680" y="1353312"/>
-            <a:ext cx="7406640" cy="3363271"/>
+            <a:off x="1005840" y="1316736"/>
+            <a:ext cx="7132320" cy="3338850"/>
           </a:xfrm>
           <a:prstGeom prst="rect">
             <a:avLst/>
@@ -5958,7 +5958,7 @@
         </p:nvSpPr>
         <p:spPr>
           <a:xfrm>
-            <a:off x="457200" y="4645152"/>
+            <a:off x="457200" y="4736592"/>
             <a:ext cx="8229600" cy="256032"/>
           </a:xfrm>
           <a:prstGeom prst="rect">
@@ -5984,7 +5984,7 @@
                 </a:solidFill>
                 <a:latin typeface="Arial"/>
               </a:rPr>
-              <a:t>Left: the regions a tracker nominates. Right: the flow returned, computed only inside them. Held-out VKITTI 2.</a:t>
+              <a:t>Left: the regions a tracker nominates. Right: the flow returned. Held-out VKITTI 2.</a:t>
             </a:r>
           </a:p>
         </p:txBody>
@@ -7822,7 +7822,7 @@
       </p:sp>
       <p:pic>
         <p:nvPicPr>
-          <p:cNvPr id="5" name="Picture 4" descr="scenarios_tartanair.png"/>
+          <p:cNvPr id="5" name="Picture 4" descr="scenarios_tartanair_tight.png"/>
           <p:cNvPicPr>
             <a:picLocks noChangeAspect="1"/>
           </p:cNvPicPr>
@@ -7836,8 +7836,8 @@
         </p:blipFill>
         <p:spPr>
           <a:xfrm>
-            <a:off x="2788920" y="1353312"/>
-            <a:ext cx="3632141" cy="3127248"/>
+            <a:off x="2926080" y="1316736"/>
+            <a:ext cx="3291049" cy="3182112"/>
           </a:xfrm>
           <a:prstGeom prst="rect">
             <a:avLst/>
@@ -7852,7 +7852,7 @@
         </p:nvSpPr>
         <p:spPr>
           <a:xfrm>
-            <a:off x="457200" y="4617720"/>
+            <a:off x="457200" y="4736592"/>
             <a:ext cx="8229600" cy="256032"/>
           </a:xfrm>
           <a:prstGeom prst="rect">
@@ -7878,7 +7878,7 @@
                 </a:solidFill>
                 <a:latin typeface="Arial"/>
               </a:rPr>
-              <a:t>TartanAir aerial sequences. Region geometry and decoder configuration identical to the driving figure; no model trained on this domain.</a:t>
+              <a:t>TartanAir aerial sequences. Same region geometry as the driving figure; no model trained on this domain.</a:t>
             </a:r>
           </a:p>
         </p:txBody>

</xml_diff>